<commit_message>
Resolve v2.32 cross-file consistency issues before submission.
Align table titles/order/captions, clarify ISO baseline and hand-check notes in the supplement, fix abstract counts and EN affiliation, and label Figure 3 panels.

Co-authored-by: Cursor <cursoragent@cursor.com>
</commit_message>
<xml_diff>
--- a/docs/pilot-study/manuscripts/submission_v2.32/figures/Figure1~3_AudioScopeEDU_generation.pptx
+++ b/docs/pilot-study/manuscripts/submission_v2.32/figures/Figure1~3_AudioScopeEDU_generation.pptx
@@ -2698,7 +2698,7 @@
                 <a:ea typeface="Hiragino Sans"/>
                 <a:cs typeface="Hiragino Sans"/>
               </a:rPr>
-              <a:t>図１</a:t>
+              <a:t>図1　教育用オージオグラムの自動生成フロー</a:t>
             </a:r>
             <a:r>
               <a:rPr lang="ja-JP" altLang="en-US" sz="2400" b="1">
@@ -2709,7 +2709,7 @@
                 <a:ea typeface="Hiragino Sans"/>
                 <a:cs typeface="Hiragino Sans"/>
               </a:rPr>
-              <a:t>　生成フロー</a:t>
+              <a:t/>
             </a:r>
             <a:endParaRPr sz="2400" b="1" dirty="0">
               <a:solidFill>
@@ -2995,7 +2995,7 @@
                 <a:ea typeface="Hiragino Sans"/>
                 <a:cs typeface="Hiragino Sans"/>
               </a:rPr>
-              <a:t>図2</a:t>
+              <a:t>図2　AudioScope EDUのオージオグラム提示画面</a:t>
             </a:r>
             <a:r>
               <a:rPr lang="ja-JP" altLang="en-US" sz="2400" b="1">
@@ -3006,7 +3006,7 @@
                 <a:ea typeface="Hiragino Sans"/>
                 <a:cs typeface="Hiragino Sans"/>
               </a:rPr>
-              <a:t>　</a:t>
+              <a:t/>
             </a:r>
             <a:r>
               <a:rPr lang="en-US" altLang="ja-JP" sz="2400" b="1" dirty="0" err="1">
@@ -3017,7 +3017,7 @@
                 <a:ea typeface="Hiragino Sans"/>
                 <a:cs typeface="Hiragino Sans"/>
               </a:rPr>
-              <a:t>AudioScope</a:t>
+              <a:t/>
             </a:r>
             <a:r>
               <a:rPr lang="en-US" altLang="ja-JP" sz="2400" b="1" dirty="0">
@@ -3028,7 +3028,7 @@
                 <a:ea typeface="Hiragino Sans"/>
                 <a:cs typeface="Hiragino Sans"/>
               </a:rPr>
-              <a:t> EDU </a:t>
+              <a:t/>
             </a:r>
             <a:r>
               <a:rPr lang="ja-JP" altLang="en-US" sz="2400" b="1">
@@ -3039,7 +3039,7 @@
                 <a:ea typeface="Hiragino Sans"/>
                 <a:cs typeface="Hiragino Sans"/>
               </a:rPr>
-              <a:t>画面</a:t>
+              <a:t/>
             </a:r>
             <a:endParaRPr sz="2400" b="1" dirty="0">
               <a:solidFill>
@@ -3402,7 +3402,7 @@
                 <a:ea typeface="Hiragino Sans"/>
                 <a:cs typeface="Hiragino Sans"/>
               </a:rPr>
-              <a:t>図3</a:t>
+              <a:t>図3　自動生成した代表オージオグラム</a:t>
             </a:r>
             <a:r>
               <a:rPr lang="ja-JP" altLang="en-US" sz="2400" b="1">
@@ -3413,7 +3413,7 @@
                 <a:ea typeface="Hiragino Sans"/>
                 <a:cs typeface="Hiragino Sans"/>
               </a:rPr>
-              <a:t>　生成されたオージオグラム</a:t>
+              <a:t/>
             </a:r>
             <a:endParaRPr sz="2400" b="1" dirty="0">
               <a:solidFill>
@@ -3735,6 +3735,286 @@
           </p:spPr>
         </p:pic>
       </p:grpSp>
+      <p:sp>
+        <p:nvSpPr>
+          <p:cNvPr id="38" name="TextBox 37"/>
+          <p:cNvSpPr txBox="1"/>
+          <p:nvPr/>
+        </p:nvSpPr>
+        <p:spPr>
+          <a:xfrm>
+            <a:off x="3259610" y="0"/>
+            <a:ext cx="2675188" cy="256032"/>
+          </a:xfrm>
+          <a:prstGeom prst="rect">
+            <a:avLst/>
+          </a:prstGeom>
+          <a:noFill/>
+        </p:spPr>
+        <p:txBody>
+          <a:bodyPr wrap="none">
+            <a:spAutoFit/>
+          </a:bodyPr>
+          <a:lstStyle/>
+          <a:p>
+            <a:pPr>
+              <a:defRPr sz="1100" b="1">
+                <a:solidFill>
+                  <a:srgbClr val="222222"/>
+                </a:solidFill>
+              </a:defRPr>
+            </a:pPr>
+            <a:r>
+              <a:t>b 滲出性中耳炎</a:t>
+            </a:r>
+          </a:p>
+        </p:txBody>
+      </p:sp>
+      <p:sp>
+        <p:nvSpPr>
+          <p:cNvPr id="39" name="TextBox 38"/>
+          <p:cNvSpPr txBox="1"/>
+          <p:nvPr/>
+        </p:nvSpPr>
+        <p:spPr>
+          <a:xfrm>
+            <a:off x="509324" y="2994566"/>
+            <a:ext cx="2675188" cy="256032"/>
+          </a:xfrm>
+          <a:prstGeom prst="rect">
+            <a:avLst/>
+          </a:prstGeom>
+          <a:noFill/>
+        </p:spPr>
+        <p:txBody>
+          <a:bodyPr wrap="none">
+            <a:spAutoFit/>
+          </a:bodyPr>
+          <a:lstStyle/>
+          <a:p>
+            <a:pPr>
+              <a:defRPr sz="1100" b="1">
+                <a:solidFill>
+                  <a:srgbClr val="222222"/>
+                </a:solidFill>
+              </a:defRPr>
+            </a:pPr>
+            <a:r>
+              <a:t>e メニエール病</a:t>
+            </a:r>
+          </a:p>
+        </p:txBody>
+      </p:sp>
+      <p:sp>
+        <p:nvSpPr>
+          <p:cNvPr id="40" name="TextBox 39"/>
+          <p:cNvSpPr txBox="1"/>
+          <p:nvPr/>
+        </p:nvSpPr>
+        <p:spPr>
+          <a:xfrm>
+            <a:off x="8729228" y="2986488"/>
+            <a:ext cx="2675188" cy="256032"/>
+          </a:xfrm>
+          <a:prstGeom prst="rect">
+            <a:avLst/>
+          </a:prstGeom>
+          <a:noFill/>
+        </p:spPr>
+        <p:txBody>
+          <a:bodyPr wrap="none">
+            <a:spAutoFit/>
+          </a:bodyPr>
+          <a:lstStyle/>
+          <a:p>
+            <a:pPr>
+              <a:defRPr sz="1100" b="1">
+                <a:solidFill>
+                  <a:srgbClr val="222222"/>
+                </a:solidFill>
+              </a:defRPr>
+            </a:pPr>
+            <a:r>
+              <a:t>h 伝音難聴例</a:t>
+            </a:r>
+          </a:p>
+        </p:txBody>
+      </p:sp>
+      <p:sp>
+        <p:nvSpPr>
+          <p:cNvPr id="41" name="TextBox 40"/>
+          <p:cNvSpPr txBox="1"/>
+          <p:nvPr/>
+        </p:nvSpPr>
+        <p:spPr>
+          <a:xfrm>
+            <a:off x="532539" y="0"/>
+            <a:ext cx="2675188" cy="256032"/>
+          </a:xfrm>
+          <a:prstGeom prst="rect">
+            <a:avLst/>
+          </a:prstGeom>
+          <a:noFill/>
+        </p:spPr>
+        <p:txBody>
+          <a:bodyPr wrap="none">
+            <a:spAutoFit/>
+          </a:bodyPr>
+          <a:lstStyle/>
+          <a:p>
+            <a:pPr>
+              <a:defRPr sz="1100" b="1">
+                <a:solidFill>
+                  <a:srgbClr val="222222"/>
+                </a:solidFill>
+              </a:defRPr>
+            </a:pPr>
+            <a:r>
+              <a:t>a 耳硬化症</a:t>
+            </a:r>
+          </a:p>
+        </p:txBody>
+      </p:sp>
+      <p:sp>
+        <p:nvSpPr>
+          <p:cNvPr id="42" name="TextBox 41"/>
+          <p:cNvSpPr txBox="1"/>
+          <p:nvPr/>
+        </p:nvSpPr>
+        <p:spPr>
+          <a:xfrm>
+            <a:off x="5994419" y="2986489"/>
+            <a:ext cx="2675188" cy="256032"/>
+          </a:xfrm>
+          <a:prstGeom prst="rect">
+            <a:avLst/>
+          </a:prstGeom>
+          <a:noFill/>
+        </p:spPr>
+        <p:txBody>
+          <a:bodyPr wrap="none">
+            <a:spAutoFit/>
+          </a:bodyPr>
+          <a:lstStyle/>
+          <a:p>
+            <a:pPr>
+              <a:defRPr sz="1100" b="1">
+                <a:solidFill>
+                  <a:srgbClr val="222222"/>
+                </a:solidFill>
+              </a:defRPr>
+            </a:pPr>
+            <a:r>
+              <a:t>g 急性中耳炎</a:t>
+            </a:r>
+          </a:p>
+        </p:txBody>
+      </p:sp>
+      <p:sp>
+        <p:nvSpPr>
+          <p:cNvPr id="43" name="TextBox 42"/>
+          <p:cNvSpPr txBox="1"/>
+          <p:nvPr/>
+        </p:nvSpPr>
+        <p:spPr>
+          <a:xfrm>
+            <a:off x="8729228" y="0"/>
+            <a:ext cx="2675188" cy="256032"/>
+          </a:xfrm>
+          <a:prstGeom prst="rect">
+            <a:avLst/>
+          </a:prstGeom>
+          <a:noFill/>
+        </p:spPr>
+        <p:txBody>
+          <a:bodyPr wrap="none">
+            <a:spAutoFit/>
+          </a:bodyPr>
+          <a:lstStyle/>
+          <a:p>
+            <a:pPr>
+              <a:defRPr sz="1100" b="1">
+                <a:solidFill>
+                  <a:srgbClr val="222222"/>
+                </a:solidFill>
+              </a:defRPr>
+            </a:pPr>
+            <a:r>
+              <a:t>d 騒音性難聴</a:t>
+            </a:r>
+          </a:p>
+        </p:txBody>
+      </p:sp>
+      <p:sp>
+        <p:nvSpPr>
+          <p:cNvPr id="44" name="TextBox 43"/>
+          <p:cNvSpPr txBox="1"/>
+          <p:nvPr/>
+        </p:nvSpPr>
+        <p:spPr>
+          <a:xfrm>
+            <a:off x="3244133" y="2986489"/>
+            <a:ext cx="2690665" cy="256032"/>
+          </a:xfrm>
+          <a:prstGeom prst="rect">
+            <a:avLst/>
+          </a:prstGeom>
+          <a:noFill/>
+        </p:spPr>
+        <p:txBody>
+          <a:bodyPr wrap="none">
+            <a:spAutoFit/>
+          </a:bodyPr>
+          <a:lstStyle/>
+          <a:p>
+            <a:pPr>
+              <a:defRPr sz="1100" b="1">
+                <a:solidFill>
+                  <a:srgbClr val="222222"/>
+                </a:solidFill>
+              </a:defRPr>
+            </a:pPr>
+            <a:r>
+              <a:t>f 突発性難聴</a:t>
+            </a:r>
+          </a:p>
+        </p:txBody>
+      </p:sp>
+      <p:sp>
+        <p:nvSpPr>
+          <p:cNvPr id="45" name="TextBox 44"/>
+          <p:cNvSpPr txBox="1"/>
+          <p:nvPr/>
+        </p:nvSpPr>
+        <p:spPr>
+          <a:xfrm>
+            <a:off x="5986681" y="0"/>
+            <a:ext cx="2690664" cy="256032"/>
+          </a:xfrm>
+          <a:prstGeom prst="rect">
+            <a:avLst/>
+          </a:prstGeom>
+          <a:noFill/>
+        </p:spPr>
+        <p:txBody>
+          <a:bodyPr wrap="none">
+            <a:spAutoFit/>
+          </a:bodyPr>
+          <a:lstStyle/>
+          <a:p>
+            <a:pPr>
+              <a:defRPr sz="1100" b="1">
+                <a:solidFill>
+                  <a:srgbClr val="222222"/>
+                </a:solidFill>
+              </a:defRPr>
+            </a:pPr>
+            <a:r>
+              <a:t>c 加齢性感音難聴</a:t>
+            </a:r>
+          </a:p>
+        </p:txBody>
+      </p:sp>
     </p:spTree>
     <p:extLst>
       <p:ext uri="{BB962C8B-B14F-4D97-AF65-F5344CB8AC3E}">

</xml_diff>

<commit_message>
Restore submission figures PPTX after python-pptx save corruption.
Reinstate the pre-labeling Figure1–3 pack so embedded slide images are intact again.

Co-authored-by: Cursor <cursoragent@cursor.com>
</commit_message>
<xml_diff>
--- a/docs/pilot-study/manuscripts/submission_v2.32/figures/Figure1~3_AudioScopeEDU_generation.pptx
+++ b/docs/pilot-study/manuscripts/submission_v2.32/figures/Figure1~3_AudioScopeEDU_generation.pptx
@@ -2698,7 +2698,7 @@
                 <a:ea typeface="Hiragino Sans"/>
                 <a:cs typeface="Hiragino Sans"/>
               </a:rPr>
-              <a:t>図1　教育用オージオグラムの自動生成フロー</a:t>
+              <a:t>図１</a:t>
             </a:r>
             <a:r>
               <a:rPr lang="ja-JP" altLang="en-US" sz="2400" b="1">
@@ -2709,7 +2709,7 @@
                 <a:ea typeface="Hiragino Sans"/>
                 <a:cs typeface="Hiragino Sans"/>
               </a:rPr>
-              <a:t/>
+              <a:t>　生成フロー</a:t>
             </a:r>
             <a:endParaRPr sz="2400" b="1" dirty="0">
               <a:solidFill>
@@ -2995,7 +2995,7 @@
                 <a:ea typeface="Hiragino Sans"/>
                 <a:cs typeface="Hiragino Sans"/>
               </a:rPr>
-              <a:t>図2　AudioScope EDUのオージオグラム提示画面</a:t>
+              <a:t>図2</a:t>
             </a:r>
             <a:r>
               <a:rPr lang="ja-JP" altLang="en-US" sz="2400" b="1">
@@ -3006,7 +3006,7 @@
                 <a:ea typeface="Hiragino Sans"/>
                 <a:cs typeface="Hiragino Sans"/>
               </a:rPr>
-              <a:t/>
+              <a:t>　</a:t>
             </a:r>
             <a:r>
               <a:rPr lang="en-US" altLang="ja-JP" sz="2400" b="1" dirty="0" err="1">
@@ -3017,7 +3017,7 @@
                 <a:ea typeface="Hiragino Sans"/>
                 <a:cs typeface="Hiragino Sans"/>
               </a:rPr>
-              <a:t/>
+              <a:t>AudioScope</a:t>
             </a:r>
             <a:r>
               <a:rPr lang="en-US" altLang="ja-JP" sz="2400" b="1" dirty="0">
@@ -3028,7 +3028,7 @@
                 <a:ea typeface="Hiragino Sans"/>
                 <a:cs typeface="Hiragino Sans"/>
               </a:rPr>
-              <a:t/>
+              <a:t> EDU </a:t>
             </a:r>
             <a:r>
               <a:rPr lang="ja-JP" altLang="en-US" sz="2400" b="1">
@@ -3039,7 +3039,7 @@
                 <a:ea typeface="Hiragino Sans"/>
                 <a:cs typeface="Hiragino Sans"/>
               </a:rPr>
-              <a:t/>
+              <a:t>画面</a:t>
             </a:r>
             <a:endParaRPr sz="2400" b="1" dirty="0">
               <a:solidFill>
@@ -3402,7 +3402,7 @@
                 <a:ea typeface="Hiragino Sans"/>
                 <a:cs typeface="Hiragino Sans"/>
               </a:rPr>
-              <a:t>図3　自動生成した代表オージオグラム</a:t>
+              <a:t>図3</a:t>
             </a:r>
             <a:r>
               <a:rPr lang="ja-JP" altLang="en-US" sz="2400" b="1">
@@ -3413,7 +3413,7 @@
                 <a:ea typeface="Hiragino Sans"/>
                 <a:cs typeface="Hiragino Sans"/>
               </a:rPr>
-              <a:t/>
+              <a:t>　生成されたオージオグラム</a:t>
             </a:r>
             <a:endParaRPr sz="2400" b="1" dirty="0">
               <a:solidFill>
@@ -3735,286 +3735,6 @@
           </p:spPr>
         </p:pic>
       </p:grpSp>
-      <p:sp>
-        <p:nvSpPr>
-          <p:cNvPr id="38" name="TextBox 37"/>
-          <p:cNvSpPr txBox="1"/>
-          <p:nvPr/>
-        </p:nvSpPr>
-        <p:spPr>
-          <a:xfrm>
-            <a:off x="3259610" y="0"/>
-            <a:ext cx="2675188" cy="256032"/>
-          </a:xfrm>
-          <a:prstGeom prst="rect">
-            <a:avLst/>
-          </a:prstGeom>
-          <a:noFill/>
-        </p:spPr>
-        <p:txBody>
-          <a:bodyPr wrap="none">
-            <a:spAutoFit/>
-          </a:bodyPr>
-          <a:lstStyle/>
-          <a:p>
-            <a:pPr>
-              <a:defRPr sz="1100" b="1">
-                <a:solidFill>
-                  <a:srgbClr val="222222"/>
-                </a:solidFill>
-              </a:defRPr>
-            </a:pPr>
-            <a:r>
-              <a:t>b 滲出性中耳炎</a:t>
-            </a:r>
-          </a:p>
-        </p:txBody>
-      </p:sp>
-      <p:sp>
-        <p:nvSpPr>
-          <p:cNvPr id="39" name="TextBox 38"/>
-          <p:cNvSpPr txBox="1"/>
-          <p:nvPr/>
-        </p:nvSpPr>
-        <p:spPr>
-          <a:xfrm>
-            <a:off x="509324" y="2994566"/>
-            <a:ext cx="2675188" cy="256032"/>
-          </a:xfrm>
-          <a:prstGeom prst="rect">
-            <a:avLst/>
-          </a:prstGeom>
-          <a:noFill/>
-        </p:spPr>
-        <p:txBody>
-          <a:bodyPr wrap="none">
-            <a:spAutoFit/>
-          </a:bodyPr>
-          <a:lstStyle/>
-          <a:p>
-            <a:pPr>
-              <a:defRPr sz="1100" b="1">
-                <a:solidFill>
-                  <a:srgbClr val="222222"/>
-                </a:solidFill>
-              </a:defRPr>
-            </a:pPr>
-            <a:r>
-              <a:t>e メニエール病</a:t>
-            </a:r>
-          </a:p>
-        </p:txBody>
-      </p:sp>
-      <p:sp>
-        <p:nvSpPr>
-          <p:cNvPr id="40" name="TextBox 39"/>
-          <p:cNvSpPr txBox="1"/>
-          <p:nvPr/>
-        </p:nvSpPr>
-        <p:spPr>
-          <a:xfrm>
-            <a:off x="8729228" y="2986488"/>
-            <a:ext cx="2675188" cy="256032"/>
-          </a:xfrm>
-          <a:prstGeom prst="rect">
-            <a:avLst/>
-          </a:prstGeom>
-          <a:noFill/>
-        </p:spPr>
-        <p:txBody>
-          <a:bodyPr wrap="none">
-            <a:spAutoFit/>
-          </a:bodyPr>
-          <a:lstStyle/>
-          <a:p>
-            <a:pPr>
-              <a:defRPr sz="1100" b="1">
-                <a:solidFill>
-                  <a:srgbClr val="222222"/>
-                </a:solidFill>
-              </a:defRPr>
-            </a:pPr>
-            <a:r>
-              <a:t>h 伝音難聴例</a:t>
-            </a:r>
-          </a:p>
-        </p:txBody>
-      </p:sp>
-      <p:sp>
-        <p:nvSpPr>
-          <p:cNvPr id="41" name="TextBox 40"/>
-          <p:cNvSpPr txBox="1"/>
-          <p:nvPr/>
-        </p:nvSpPr>
-        <p:spPr>
-          <a:xfrm>
-            <a:off x="532539" y="0"/>
-            <a:ext cx="2675188" cy="256032"/>
-          </a:xfrm>
-          <a:prstGeom prst="rect">
-            <a:avLst/>
-          </a:prstGeom>
-          <a:noFill/>
-        </p:spPr>
-        <p:txBody>
-          <a:bodyPr wrap="none">
-            <a:spAutoFit/>
-          </a:bodyPr>
-          <a:lstStyle/>
-          <a:p>
-            <a:pPr>
-              <a:defRPr sz="1100" b="1">
-                <a:solidFill>
-                  <a:srgbClr val="222222"/>
-                </a:solidFill>
-              </a:defRPr>
-            </a:pPr>
-            <a:r>
-              <a:t>a 耳硬化症</a:t>
-            </a:r>
-          </a:p>
-        </p:txBody>
-      </p:sp>
-      <p:sp>
-        <p:nvSpPr>
-          <p:cNvPr id="42" name="TextBox 41"/>
-          <p:cNvSpPr txBox="1"/>
-          <p:nvPr/>
-        </p:nvSpPr>
-        <p:spPr>
-          <a:xfrm>
-            <a:off x="5994419" y="2986489"/>
-            <a:ext cx="2675188" cy="256032"/>
-          </a:xfrm>
-          <a:prstGeom prst="rect">
-            <a:avLst/>
-          </a:prstGeom>
-          <a:noFill/>
-        </p:spPr>
-        <p:txBody>
-          <a:bodyPr wrap="none">
-            <a:spAutoFit/>
-          </a:bodyPr>
-          <a:lstStyle/>
-          <a:p>
-            <a:pPr>
-              <a:defRPr sz="1100" b="1">
-                <a:solidFill>
-                  <a:srgbClr val="222222"/>
-                </a:solidFill>
-              </a:defRPr>
-            </a:pPr>
-            <a:r>
-              <a:t>g 急性中耳炎</a:t>
-            </a:r>
-          </a:p>
-        </p:txBody>
-      </p:sp>
-      <p:sp>
-        <p:nvSpPr>
-          <p:cNvPr id="43" name="TextBox 42"/>
-          <p:cNvSpPr txBox="1"/>
-          <p:nvPr/>
-        </p:nvSpPr>
-        <p:spPr>
-          <a:xfrm>
-            <a:off x="8729228" y="0"/>
-            <a:ext cx="2675188" cy="256032"/>
-          </a:xfrm>
-          <a:prstGeom prst="rect">
-            <a:avLst/>
-          </a:prstGeom>
-          <a:noFill/>
-        </p:spPr>
-        <p:txBody>
-          <a:bodyPr wrap="none">
-            <a:spAutoFit/>
-          </a:bodyPr>
-          <a:lstStyle/>
-          <a:p>
-            <a:pPr>
-              <a:defRPr sz="1100" b="1">
-                <a:solidFill>
-                  <a:srgbClr val="222222"/>
-                </a:solidFill>
-              </a:defRPr>
-            </a:pPr>
-            <a:r>
-              <a:t>d 騒音性難聴</a:t>
-            </a:r>
-          </a:p>
-        </p:txBody>
-      </p:sp>
-      <p:sp>
-        <p:nvSpPr>
-          <p:cNvPr id="44" name="TextBox 43"/>
-          <p:cNvSpPr txBox="1"/>
-          <p:nvPr/>
-        </p:nvSpPr>
-        <p:spPr>
-          <a:xfrm>
-            <a:off x="3244133" y="2986489"/>
-            <a:ext cx="2690665" cy="256032"/>
-          </a:xfrm>
-          <a:prstGeom prst="rect">
-            <a:avLst/>
-          </a:prstGeom>
-          <a:noFill/>
-        </p:spPr>
-        <p:txBody>
-          <a:bodyPr wrap="none">
-            <a:spAutoFit/>
-          </a:bodyPr>
-          <a:lstStyle/>
-          <a:p>
-            <a:pPr>
-              <a:defRPr sz="1100" b="1">
-                <a:solidFill>
-                  <a:srgbClr val="222222"/>
-                </a:solidFill>
-              </a:defRPr>
-            </a:pPr>
-            <a:r>
-              <a:t>f 突発性難聴</a:t>
-            </a:r>
-          </a:p>
-        </p:txBody>
-      </p:sp>
-      <p:sp>
-        <p:nvSpPr>
-          <p:cNvPr id="45" name="TextBox 44"/>
-          <p:cNvSpPr txBox="1"/>
-          <p:nvPr/>
-        </p:nvSpPr>
-        <p:spPr>
-          <a:xfrm>
-            <a:off x="5986681" y="0"/>
-            <a:ext cx="2690664" cy="256032"/>
-          </a:xfrm>
-          <a:prstGeom prst="rect">
-            <a:avLst/>
-          </a:prstGeom>
-          <a:noFill/>
-        </p:spPr>
-        <p:txBody>
-          <a:bodyPr wrap="none">
-            <a:spAutoFit/>
-          </a:bodyPr>
-          <a:lstStyle/>
-          <a:p>
-            <a:pPr>
-              <a:defRPr sz="1100" b="1">
-                <a:solidFill>
-                  <a:srgbClr val="222222"/>
-                </a:solidFill>
-              </a:defRPr>
-            </a:pPr>
-            <a:r>
-              <a:t>c 加齢性感音難聴</a:t>
-            </a:r>
-          </a:p>
-        </p:txBody>
-      </p:sp>
     </p:spTree>
     <p:extLst>
       <p:ext uri="{BB962C8B-B14F-4D97-AF65-F5344CB8AC3E}">

</xml_diff>